<commit_message>
Add chart components CR-05 pie and CR-06 bar with theme colors
Co-Authored-By: Claude Fable 5 <noreply@anthropic.com>
</commit_message>
<xml_diff>
--- a/domains/customer-review/assets/components/customer-review-components.pptx
+++ b/domains/customer-review/assets/components/customer-review-components.pptx
@@ -9,6 +9,8 @@
     <p:sldId id="257" r:id="rId8"/>
     <p:sldId id="258" r:id="rId9"/>
     <p:sldId id="259" r:id="rId10"/>
+    <p:sldId id="260" r:id="rId11"/>
+    <p:sldId id="261" r:id="rId12"/>
   </p:sldIdLst>
   <p:sldSz cx="12192000" cy="6858000" type="screen4x3"/>
   <p:notesSz cx="6858000" cy="9144000"/>
@@ -108,6 +110,346 @@
     </a:lvl9pPr>
   </p:defaultTextStyle>
 </p:presentation>
+</file>
+
+<file path=ppt/charts/chart1.xml><?xml version="1.0" encoding="utf-8"?>
+<c:chartSpace xmlns:c="http://schemas.openxmlformats.org/drawingml/2006/chart" xmlns:a="http://schemas.openxmlformats.org/drawingml/2006/main" xmlns:r="http://schemas.openxmlformats.org/officeDocument/2006/relationships">
+  <c:chart>
+    <c:autoTitleDeleted val="0"/>
+    <c:plotArea>
+      <c:pieChart>
+        <c:varyColors val="1"/>
+        <c:ser>
+          <c:idx val="0"/>
+          <c:order val="0"/>
+          <c:tx>
+            <c:strRef>
+              <c:f>Sheet1!$B$1</c:f>
+              <c:strCache>
+                <c:ptCount val="1"/>
+                <c:pt idx="0">
+                  <c:v>销售额占比</c:v>
+                </c:pt>
+              </c:strCache>
+            </c:strRef>
+          </c:tx>
+          <c:dPt>
+            <c:idx val="0"/>
+            <c:spPr>
+              <a:solidFill>
+                <a:schemeClr val="accent1"/>
+              </a:solidFill>
+            </c:spPr>
+          </c:dPt>
+          <c:dPt>
+            <c:idx val="1"/>
+            <c:spPr>
+              <a:solidFill>
+                <a:schemeClr val="accent6"/>
+              </a:solidFill>
+            </c:spPr>
+          </c:dPt>
+          <c:dPt>
+            <c:idx val="2"/>
+            <c:spPr>
+              <a:solidFill>
+                <a:schemeClr val="accent4"/>
+              </a:solidFill>
+            </c:spPr>
+          </c:dPt>
+          <c:dPt>
+            <c:idx val="3"/>
+            <c:spPr>
+              <a:solidFill>
+                <a:schemeClr val="accent5"/>
+              </a:solidFill>
+            </c:spPr>
+          </c:dPt>
+          <c:cat>
+            <c:strRef>
+              <c:f>Sheet1!$A$2:$A$5</c:f>
+              <c:strCache>
+                <c:ptCount val="4"/>
+                <c:pt idx="0">
+                  <c:v>A 级</c:v>
+                </c:pt>
+                <c:pt idx="1">
+                  <c:v>B 级</c:v>
+                </c:pt>
+                <c:pt idx="2">
+                  <c:v>C 级</c:v>
+                </c:pt>
+                <c:pt idx="3">
+                  <c:v>D 级</c:v>
+                </c:pt>
+              </c:strCache>
+            </c:strRef>
+          </c:cat>
+          <c:val>
+            <c:numRef>
+              <c:f>Sheet1!$B$2:$B$5</c:f>
+              <c:numCache>
+                <c:formatCode>General</c:formatCode>
+                <c:ptCount val="4"/>
+                <c:pt idx="0">
+                  <c:v>60</c:v>
+                </c:pt>
+                <c:pt idx="1">
+                  <c:v>25</c:v>
+                </c:pt>
+                <c:pt idx="2">
+                  <c:v>10</c:v>
+                </c:pt>
+                <c:pt idx="3">
+                  <c:v>5</c:v>
+                </c:pt>
+              </c:numCache>
+            </c:numRef>
+          </c:val>
+        </c:ser>
+      </c:pieChart>
+    </c:plotArea>
+    <c:legend>
+      <c:legendPos/>
+      <c:overlay val="0"/>
+    </c:legend>
+    <c:dispBlanksAs val="gap"/>
+  </c:chart>
+  <c:txPr>
+    <a:bodyPr/>
+    <a:lstStyle/>
+    <a:p>
+      <a:pPr>
+        <a:defRPr sz="1800"/>
+      </a:pPr>
+      <a:endParaRPr lang="en-US"/>
+    </a:p>
+  </c:txPr>
+  <c:externalData r:id="rId1">
+    <c:autoUpdate val="0"/>
+  </c:externalData>
+  <c:spPr>
+    <a:noFill/>
+    <a:ln>
+      <a:noFill/>
+    </a:ln>
+  </c:spPr>
+</c:chartSpace>
+</file>
+
+<file path=ppt/charts/chart2.xml><?xml version="1.0" encoding="utf-8"?>
+<c:chartSpace xmlns:c="http://schemas.openxmlformats.org/drawingml/2006/chart" xmlns:a="http://schemas.openxmlformats.org/drawingml/2006/main" xmlns:r="http://schemas.openxmlformats.org/officeDocument/2006/relationships">
+  <c:date1904 val="0"/>
+  <c:chart>
+    <c:autoTitleDeleted val="0"/>
+    <c:plotArea>
+      <c:barChart>
+        <c:barDir val="bar"/>
+        <c:grouping val="clustered"/>
+        <c:ser>
+          <c:idx val="0"/>
+          <c:order val="0"/>
+          <c:tx>
+            <c:strRef>
+              <c:f>Sheet1!$B$1</c:f>
+              <c:strCache>
+                <c:ptCount val="1"/>
+                <c:pt idx="0">
+                  <c:v>销售额</c:v>
+                </c:pt>
+              </c:strCache>
+            </c:strRef>
+          </c:tx>
+          <c:spPr>
+            <a:solidFill>
+              <a:schemeClr val="accent1"/>
+            </a:solidFill>
+          </c:spPr>
+          <c:cat>
+            <c:strRef>
+              <c:f>Sheet1!$A$2:$A$7</c:f>
+              <c:strCache>
+                <c:ptCount val="6"/>
+                <c:pt idx="0">
+                  <c:v>1月</c:v>
+                </c:pt>
+                <c:pt idx="1">
+                  <c:v>2月</c:v>
+                </c:pt>
+                <c:pt idx="2">
+                  <c:v>3月</c:v>
+                </c:pt>
+                <c:pt idx="3">
+                  <c:v>4月</c:v>
+                </c:pt>
+                <c:pt idx="4">
+                  <c:v>5月</c:v>
+                </c:pt>
+                <c:pt idx="5">
+                  <c:v>6月</c:v>
+                </c:pt>
+              </c:strCache>
+            </c:strRef>
+          </c:cat>
+          <c:val>
+            <c:numRef>
+              <c:f>Sheet1!$B$2:$B$7</c:f>
+              <c:numCache>
+                <c:formatCode>General</c:formatCode>
+                <c:ptCount val="6"/>
+                <c:pt idx="0">
+                  <c:v>100</c:v>
+                </c:pt>
+                <c:pt idx="1">
+                  <c:v>90</c:v>
+                </c:pt>
+                <c:pt idx="2">
+                  <c:v>60</c:v>
+                </c:pt>
+                <c:pt idx="3">
+                  <c:v>50</c:v>
+                </c:pt>
+                <c:pt idx="4">
+                  <c:v>75</c:v>
+                </c:pt>
+                <c:pt idx="5">
+                  <c:v>60</c:v>
+                </c:pt>
+              </c:numCache>
+            </c:numRef>
+          </c:val>
+        </c:ser>
+        <c:ser>
+          <c:idx val="1"/>
+          <c:order val="1"/>
+          <c:tx>
+            <c:strRef>
+              <c:f>Sheet1!$C$1</c:f>
+              <c:strCache>
+                <c:ptCount val="1"/>
+                <c:pt idx="0">
+                  <c:v>毛利</c:v>
+                </c:pt>
+              </c:strCache>
+            </c:strRef>
+          </c:tx>
+          <c:spPr>
+            <a:solidFill>
+              <a:schemeClr val="accent4"/>
+            </a:solidFill>
+          </c:spPr>
+          <c:cat>
+            <c:strRef>
+              <c:f>Sheet1!$A$2:$A$7</c:f>
+              <c:strCache>
+                <c:ptCount val="6"/>
+                <c:pt idx="0">
+                  <c:v>1月</c:v>
+                </c:pt>
+                <c:pt idx="1">
+                  <c:v>2月</c:v>
+                </c:pt>
+                <c:pt idx="2">
+                  <c:v>3月</c:v>
+                </c:pt>
+                <c:pt idx="3">
+                  <c:v>4月</c:v>
+                </c:pt>
+                <c:pt idx="4">
+                  <c:v>5月</c:v>
+                </c:pt>
+                <c:pt idx="5">
+                  <c:v>6月</c:v>
+                </c:pt>
+              </c:strCache>
+            </c:strRef>
+          </c:cat>
+          <c:val>
+            <c:numRef>
+              <c:f>Sheet1!$C$2:$C$7</c:f>
+              <c:numCache>
+                <c:formatCode>General</c:formatCode>
+                <c:ptCount val="6"/>
+                <c:pt idx="0">
+                  <c:v>20</c:v>
+                </c:pt>
+                <c:pt idx="1">
+                  <c:v>18</c:v>
+                </c:pt>
+                <c:pt idx="2">
+                  <c:v>12</c:v>
+                </c:pt>
+                <c:pt idx="3">
+                  <c:v>10</c:v>
+                </c:pt>
+                <c:pt idx="4">
+                  <c:v>15</c:v>
+                </c:pt>
+                <c:pt idx="5">
+                  <c:v>12</c:v>
+                </c:pt>
+              </c:numCache>
+            </c:numRef>
+          </c:val>
+        </c:ser>
+        <c:axId val="-2068027336"/>
+        <c:axId val="-2113994440"/>
+      </c:barChart>
+      <c:catAx>
+        <c:axId val="-2068027336"/>
+        <c:scaling>
+          <c:orientation val="minMax"/>
+        </c:scaling>
+        <c:delete val="0"/>
+        <c:axPos val="l"/>
+        <c:majorTickMark val="out"/>
+        <c:minorTickMark val="none"/>
+        <c:tickLblPos val="nextTo"/>
+        <c:crossAx val="-2113994440"/>
+        <c:crosses val="autoZero"/>
+        <c:auto val="1"/>
+        <c:lblAlgn val="ctr"/>
+        <c:lblOffset val="100"/>
+        <c:noMultiLvlLbl val="0"/>
+      </c:catAx>
+      <c:valAx>
+        <c:axId val="-2113994440"/>
+        <c:scaling/>
+        <c:delete val="0"/>
+        <c:axPos val="b"/>
+        <c:majorTickMark val="out"/>
+        <c:minorTickMark val="none"/>
+        <c:tickLblPos val="nextTo"/>
+        <c:crossAx val="-2068027336"/>
+        <c:crosses val="autoZero"/>
+      </c:valAx>
+    </c:plotArea>
+    <c:legend>
+      <c:legendPos/>
+      <c:overlay val="0"/>
+    </c:legend>
+    <c:dispBlanksAs val="gap"/>
+  </c:chart>
+  <c:txPr>
+    <a:bodyPr/>
+    <a:lstStyle/>
+    <a:p>
+      <a:pPr>
+        <a:defRPr sz="1800"/>
+      </a:pPr>
+      <a:endParaRPr lang="en-US"/>
+    </a:p>
+  </c:txPr>
+  <c:externalData r:id="rId1">
+    <c:autoUpdate val="0"/>
+  </c:externalData>
+  <c:spPr>
+    <a:noFill/>
+    <a:ln>
+      <a:noFill/>
+    </a:ln>
+  </c:spPr>
+</c:chartSpace>
 </file>
 
 <file path=ppt/slideLayouts/slideLayout1.xml><?xml version="1.0" encoding="utf-8"?>
@@ -6954,6 +7296,526 @@
                 <a:latin typeface="Microsoft YaHei"/>
               </a:rPr>
               <a:t>讲解提示：卡片用于 Top 客户逐一过会；建议必须标注"供参考"。</a:t>
+            </a:r>
+          </a:p>
+        </p:txBody>
+      </p:sp>
+    </p:spTree>
+  </p:cSld>
+  <p:clrMapOvr>
+    <a:masterClrMapping/>
+  </p:clrMapOvr>
+</p:sld>
+</file>
+
+<file path=ppt/slides/slide5.xml><?xml version="1.0" encoding="utf-8"?>
+<p:sld xmlns:a="http://schemas.openxmlformats.org/drawingml/2006/main" xmlns:p="http://schemas.openxmlformats.org/presentationml/2006/main" xmlns:r="http://schemas.openxmlformats.org/officeDocument/2006/relationships">
+  <p:cSld>
+    <p:spTree>
+      <p:nvGrpSpPr>
+        <p:cNvPr id="1" name=""/>
+        <p:cNvGrpSpPr/>
+        <p:nvPr/>
+      </p:nvGrpSpPr>
+      <p:grpSpPr/>
+      <p:sp>
+        <p:nvSpPr>
+          <p:cNvPr id="2" name="TOP_BAR"/>
+          <p:cNvSpPr/>
+          <p:nvPr/>
+        </p:nvSpPr>
+        <p:spPr>
+          <a:xfrm>
+            <a:off x="0" y="0"/>
+            <a:ext cx="12188952" cy="54864"/>
+          </a:xfrm>
+          <a:prstGeom prst="rect">
+            <a:avLst/>
+          </a:prstGeom>
+          <a:solidFill>
+            <a:schemeClr val="accent1"/>
+          </a:solidFill>
+          <a:ln>
+            <a:noFill/>
+          </a:ln>
+          <a:effectLst/>
+        </p:spPr>
+        <p:style>
+          <a:lnRef idx="1">
+            <a:schemeClr val="accent1"/>
+          </a:lnRef>
+          <a:fillRef idx="3">
+            <a:schemeClr val="accent1"/>
+          </a:fillRef>
+          <a:effectRef idx="2">
+            <a:schemeClr val="accent1"/>
+          </a:effectRef>
+          <a:fontRef idx="minor">
+            <a:schemeClr val="lt1"/>
+          </a:fontRef>
+        </p:style>
+        <p:txBody>
+          <a:bodyPr rtlCol="0" anchor="ctr"/>
+          <a:lstStyle/>
+          <a:p>
+            <a:pPr algn="ctr"/>
+          </a:p>
+        </p:txBody>
+      </p:sp>
+      <p:sp>
+        <p:nvSpPr>
+          <p:cNvPr id="3" name="FOOTER"/>
+          <p:cNvSpPr txBox="1"/>
+          <p:nvPr/>
+        </p:nvSpPr>
+        <p:spPr>
+          <a:xfrm>
+            <a:off x="548640" y="6455664"/>
+            <a:ext cx="11064240" cy="320040"/>
+          </a:xfrm>
+          <a:prstGeom prst="rect">
+            <a:avLst/>
+          </a:prstGeom>
+          <a:noFill/>
+        </p:spPr>
+        <p:txBody>
+          <a:bodyPr wrap="square" lIns="0" rIns="0" tIns="0" bIns="0">
+            <a:spAutoFit/>
+          </a:bodyPr>
+          <a:lstStyle/>
+          <a:p>
+            <a:pPr algn="l"/>
+            <a:r>
+              <a:rPr sz="1000" b="0">
+                <a:solidFill>
+                  <a:schemeClr val="accent5"/>
+                </a:solidFill>
+                <a:latin typeface="Microsoft YaHei"/>
+              </a:rPr>
+              <a:t>客户经营分析 · 汇报</a:t>
+            </a:r>
+          </a:p>
+        </p:txBody>
+      </p:sp>
+      <p:sp>
+        <p:nvSpPr>
+          <p:cNvPr id="4" name="TITLE"/>
+          <p:cNvSpPr txBox="1"/>
+          <p:nvPr/>
+        </p:nvSpPr>
+        <p:spPr>
+          <a:xfrm>
+            <a:off x="548640" y="384048"/>
+            <a:ext cx="10789920" cy="685800"/>
+          </a:xfrm>
+          <a:prstGeom prst="rect">
+            <a:avLst/>
+          </a:prstGeom>
+          <a:noFill/>
+        </p:spPr>
+        <p:txBody>
+          <a:bodyPr wrap="square" lIns="0" rIns="0" tIns="0" bIns="0">
+            <a:spAutoFit/>
+          </a:bodyPr>
+          <a:lstStyle/>
+          <a:p>
+            <a:pPr algn="l"/>
+            <a:r>
+              <a:rPr sz="2600" b="1">
+                <a:solidFill>
+                  <a:schemeClr val="dk1"/>
+                </a:solidFill>
+                <a:latin typeface="Microsoft YaHei"/>
+              </a:rPr>
+              <a:t>客户分层占比</a:t>
+            </a:r>
+          </a:p>
+        </p:txBody>
+      </p:sp>
+      <p:sp>
+        <p:nvSpPr>
+          <p:cNvPr id="5" name="SUBTITLE"/>
+          <p:cNvSpPr txBox="1"/>
+          <p:nvPr/>
+        </p:nvSpPr>
+        <p:spPr>
+          <a:xfrm>
+            <a:off x="548640" y="987552"/>
+            <a:ext cx="10789920" cy="457200"/>
+          </a:xfrm>
+          <a:prstGeom prst="rect">
+            <a:avLst/>
+          </a:prstGeom>
+          <a:noFill/>
+        </p:spPr>
+        <p:txBody>
+          <a:bodyPr wrap="square" lIns="0" rIns="0" tIns="0" bIns="0">
+            <a:spAutoFit/>
+          </a:bodyPr>
+          <a:lstStyle/>
+          <a:p>
+            <a:pPr algn="l"/>
+            <a:r>
+              <a:rPr sz="1400" b="0">
+                <a:solidFill>
+                  <a:schemeClr val="accent5"/>
+                </a:solidFill>
+                <a:latin typeface="Microsoft YaHei"/>
+              </a:rPr>
+              <a:t>A/B/C/D 四级销售额占比（饼图）</a:t>
+            </a:r>
+          </a:p>
+        </p:txBody>
+      </p:sp>
+      <p:graphicFrame>
+        <p:nvGraphicFramePr>
+          <p:cNvPr id="6" name="Chart 5"/>
+          <p:cNvGraphicFramePr>
+            <a:graphicFrameLocks noGrp="1"/>
+          </p:cNvGraphicFramePr>
+          <p:nvPr/>
+        </p:nvGraphicFramePr>
+        <p:xfrm>
+          <a:off x="1463040" y="1554480"/>
+          <a:ext cx="6400800" cy="4023360"/>
+        </p:xfrm>
+        <a:graphic>
+          <a:graphicData uri="http://schemas.openxmlformats.org/drawingml/2006/chart">
+            <c:chart xmlns:c="http://schemas.openxmlformats.org/drawingml/2006/chart" r:id="rId2"/>
+          </a:graphicData>
+        </a:graphic>
+      </p:graphicFrame>
+      <p:sp>
+        <p:nvSpPr>
+          <p:cNvPr id="7" name="CHART_NOTE"/>
+          <p:cNvSpPr txBox="1"/>
+          <p:nvPr/>
+        </p:nvSpPr>
+        <p:spPr>
+          <a:xfrm>
+            <a:off x="8138160" y="1828800"/>
+            <a:ext cx="3657600" cy="3474720"/>
+          </a:xfrm>
+          <a:prstGeom prst="rect">
+            <a:avLst/>
+          </a:prstGeom>
+          <a:noFill/>
+        </p:spPr>
+        <p:txBody>
+          <a:bodyPr wrap="square" lIns="0" rIns="0" tIns="0" bIns="0">
+            <a:spAutoFit/>
+          </a:bodyPr>
+          <a:lstStyle/>
+          <a:p>
+            <a:pPr algn="l">
+              <a:lnSpc>
+                <a:spcPct val="140000"/>
+              </a:lnSpc>
+            </a:pPr>
+            <a:r>
+              <a:rPr sz="1200" b="0">
+                <a:solidFill>
+                  <a:schemeClr val="accent5"/>
+                </a:solidFill>
+                <a:latin typeface="Microsoft YaHei"/>
+              </a:rPr>
+              <a:t>结论占位：A 级贡献绝大部分销售额，头部集中显著。
+数据标签显示各层级占比；替换数据时保持层级顺序 A→B→C→D。</a:t>
+            </a:r>
+          </a:p>
+        </p:txBody>
+      </p:sp>
+      <p:sp>
+        <p:nvSpPr>
+          <p:cNvPr id="8" name="TEACHING_CUE"/>
+          <p:cNvSpPr txBox="1"/>
+          <p:nvPr/>
+        </p:nvSpPr>
+        <p:spPr>
+          <a:xfrm>
+            <a:off x="548640" y="6035040"/>
+            <a:ext cx="11064240" cy="457200"/>
+          </a:xfrm>
+          <a:prstGeom prst="rect">
+            <a:avLst/>
+          </a:prstGeom>
+          <a:noFill/>
+        </p:spPr>
+        <p:txBody>
+          <a:bodyPr wrap="square" lIns="0" rIns="0" tIns="0" bIns="0">
+            <a:spAutoFit/>
+          </a:bodyPr>
+          <a:lstStyle/>
+          <a:p>
+            <a:pPr algn="l"/>
+            <a:r>
+              <a:rPr sz="1100" b="0">
+                <a:solidFill>
+                  <a:schemeClr val="accent5"/>
+                </a:solidFill>
+                <a:latin typeface="Microsoft YaHei"/>
+              </a:rPr>
+              <a:t>讲解提示：饼图回答"钱从哪里来"；与分层表（CR-02）配合使用。</a:t>
+            </a:r>
+          </a:p>
+        </p:txBody>
+      </p:sp>
+    </p:spTree>
+  </p:cSld>
+  <p:clrMapOvr>
+    <a:masterClrMapping/>
+  </p:clrMapOvr>
+</p:sld>
+</file>
+
+<file path=ppt/slides/slide6.xml><?xml version="1.0" encoding="utf-8"?>
+<p:sld xmlns:a="http://schemas.openxmlformats.org/drawingml/2006/main" xmlns:p="http://schemas.openxmlformats.org/presentationml/2006/main" xmlns:r="http://schemas.openxmlformats.org/officeDocument/2006/relationships">
+  <p:cSld>
+    <p:spTree>
+      <p:nvGrpSpPr>
+        <p:cNvPr id="1" name=""/>
+        <p:cNvGrpSpPr/>
+        <p:nvPr/>
+      </p:nvGrpSpPr>
+      <p:grpSpPr/>
+      <p:sp>
+        <p:nvSpPr>
+          <p:cNvPr id="2" name="TOP_BAR"/>
+          <p:cNvSpPr/>
+          <p:nvPr/>
+        </p:nvSpPr>
+        <p:spPr>
+          <a:xfrm>
+            <a:off x="0" y="0"/>
+            <a:ext cx="12188952" cy="54864"/>
+          </a:xfrm>
+          <a:prstGeom prst="rect">
+            <a:avLst/>
+          </a:prstGeom>
+          <a:solidFill>
+            <a:schemeClr val="accent1"/>
+          </a:solidFill>
+          <a:ln>
+            <a:noFill/>
+          </a:ln>
+          <a:effectLst/>
+        </p:spPr>
+        <p:style>
+          <a:lnRef idx="1">
+            <a:schemeClr val="accent1"/>
+          </a:lnRef>
+          <a:fillRef idx="3">
+            <a:schemeClr val="accent1"/>
+          </a:fillRef>
+          <a:effectRef idx="2">
+            <a:schemeClr val="accent1"/>
+          </a:effectRef>
+          <a:fontRef idx="minor">
+            <a:schemeClr val="lt1"/>
+          </a:fontRef>
+        </p:style>
+        <p:txBody>
+          <a:bodyPr rtlCol="0" anchor="ctr"/>
+          <a:lstStyle/>
+          <a:p>
+            <a:pPr algn="ctr"/>
+          </a:p>
+        </p:txBody>
+      </p:sp>
+      <p:sp>
+        <p:nvSpPr>
+          <p:cNvPr id="3" name="FOOTER"/>
+          <p:cNvSpPr txBox="1"/>
+          <p:nvPr/>
+        </p:nvSpPr>
+        <p:spPr>
+          <a:xfrm>
+            <a:off x="548640" y="6455664"/>
+            <a:ext cx="11064240" cy="320040"/>
+          </a:xfrm>
+          <a:prstGeom prst="rect">
+            <a:avLst/>
+          </a:prstGeom>
+          <a:noFill/>
+        </p:spPr>
+        <p:txBody>
+          <a:bodyPr wrap="square" lIns="0" rIns="0" tIns="0" bIns="0">
+            <a:spAutoFit/>
+          </a:bodyPr>
+          <a:lstStyle/>
+          <a:p>
+            <a:pPr algn="l"/>
+            <a:r>
+              <a:rPr sz="1000" b="0">
+                <a:solidFill>
+                  <a:schemeClr val="accent5"/>
+                </a:solidFill>
+                <a:latin typeface="Microsoft YaHei"/>
+              </a:rPr>
+              <a:t>客户经营分析 · 汇报</a:t>
+            </a:r>
+          </a:p>
+        </p:txBody>
+      </p:sp>
+      <p:sp>
+        <p:nvSpPr>
+          <p:cNvPr id="4" name="TITLE"/>
+          <p:cNvSpPr txBox="1"/>
+          <p:nvPr/>
+        </p:nvSpPr>
+        <p:spPr>
+          <a:xfrm>
+            <a:off x="548640" y="384048"/>
+            <a:ext cx="10789920" cy="685800"/>
+          </a:xfrm>
+          <a:prstGeom prst="rect">
+            <a:avLst/>
+          </a:prstGeom>
+          <a:noFill/>
+        </p:spPr>
+        <p:txBody>
+          <a:bodyPr wrap="square" lIns="0" rIns="0" tIns="0" bIns="0">
+            <a:spAutoFit/>
+          </a:bodyPr>
+          <a:lstStyle/>
+          <a:p>
+            <a:pPr algn="l"/>
+            <a:r>
+              <a:rPr sz="2600" b="1">
+                <a:solidFill>
+                  <a:schemeClr val="dk1"/>
+                </a:solidFill>
+                <a:latin typeface="Microsoft YaHei"/>
+              </a:rPr>
+              <a:t>月度销售趋势</a:t>
+            </a:r>
+          </a:p>
+        </p:txBody>
+      </p:sp>
+      <p:sp>
+        <p:nvSpPr>
+          <p:cNvPr id="5" name="SUBTITLE"/>
+          <p:cNvSpPr txBox="1"/>
+          <p:nvPr/>
+        </p:nvSpPr>
+        <p:spPr>
+          <a:xfrm>
+            <a:off x="548640" y="987552"/>
+            <a:ext cx="10789920" cy="457200"/>
+          </a:xfrm>
+          <a:prstGeom prst="rect">
+            <a:avLst/>
+          </a:prstGeom>
+          <a:noFill/>
+        </p:spPr>
+        <p:txBody>
+          <a:bodyPr wrap="square" lIns="0" rIns="0" tIns="0" bIns="0">
+            <a:spAutoFit/>
+          </a:bodyPr>
+          <a:lstStyle/>
+          <a:p>
+            <a:pPr algn="l"/>
+            <a:r>
+              <a:rPr sz="1400" b="0">
+                <a:solidFill>
+                  <a:schemeClr val="accent5"/>
+                </a:solidFill>
+                <a:latin typeface="Microsoft YaHei"/>
+              </a:rPr>
+              <a:t>销售额与毛利（柱状图）</a:t>
+            </a:r>
+          </a:p>
+        </p:txBody>
+      </p:sp>
+      <p:graphicFrame>
+        <p:nvGraphicFramePr>
+          <p:cNvPr id="6" name="Chart 5"/>
+          <p:cNvGraphicFramePr>
+            <a:graphicFrameLocks noGrp="1"/>
+          </p:cNvGraphicFramePr>
+          <p:nvPr/>
+        </p:nvGraphicFramePr>
+        <p:xfrm>
+          <a:off x="1463040" y="1554480"/>
+          <a:ext cx="6949440" cy="4023360"/>
+        </p:xfrm>
+        <a:graphic>
+          <a:graphicData uri="http://schemas.openxmlformats.org/drawingml/2006/chart">
+            <c:chart xmlns:c="http://schemas.openxmlformats.org/drawingml/2006/chart" r:id="rId2"/>
+          </a:graphicData>
+        </a:graphic>
+      </p:graphicFrame>
+      <p:sp>
+        <p:nvSpPr>
+          <p:cNvPr id="7" name="CHART_NOTE"/>
+          <p:cNvSpPr txBox="1"/>
+          <p:nvPr/>
+        </p:nvSpPr>
+        <p:spPr>
+          <a:xfrm>
+            <a:off x="8686800" y="1828800"/>
+            <a:ext cx="3108960" cy="3474720"/>
+          </a:xfrm>
+          <a:prstGeom prst="rect">
+            <a:avLst/>
+          </a:prstGeom>
+          <a:noFill/>
+        </p:spPr>
+        <p:txBody>
+          <a:bodyPr wrap="square" lIns="0" rIns="0" tIns="0" bIns="0">
+            <a:spAutoFit/>
+          </a:bodyPr>
+          <a:lstStyle/>
+          <a:p>
+            <a:pPr algn="l">
+              <a:lnSpc>
+                <a:spcPct val="140000"/>
+              </a:lnSpc>
+            </a:pPr>
+            <a:r>
+              <a:rPr sz="1200" b="0">
+                <a:solidFill>
+                  <a:schemeClr val="accent5"/>
+                </a:solidFill>
+                <a:latin typeface="Microsoft YaHei"/>
+              </a:rPr>
+              <a:t>结论占位：1 月为峰值，Q1 逐月回落，Q2 波动。
+柱状图回答"趋势往哪走"。</a:t>
+            </a:r>
+          </a:p>
+        </p:txBody>
+      </p:sp>
+      <p:sp>
+        <p:nvSpPr>
+          <p:cNvPr id="8" name="TEACHING_CUE"/>
+          <p:cNvSpPr txBox="1"/>
+          <p:nvPr/>
+        </p:nvSpPr>
+        <p:spPr>
+          <a:xfrm>
+            <a:off x="548640" y="6035040"/>
+            <a:ext cx="11064240" cy="457200"/>
+          </a:xfrm>
+          <a:prstGeom prst="rect">
+            <a:avLst/>
+          </a:prstGeom>
+          <a:noFill/>
+        </p:spPr>
+        <p:txBody>
+          <a:bodyPr wrap="square" lIns="0" rIns="0" tIns="0" bIns="0">
+            <a:spAutoFit/>
+          </a:bodyPr>
+          <a:lstStyle/>
+          <a:p>
+            <a:pPr algn="l"/>
+            <a:r>
+              <a:rPr sz="1100" b="0">
+                <a:solidFill>
+                  <a:schemeClr val="accent5"/>
+                </a:solidFill>
+                <a:latin typeface="Microsoft YaHei"/>
+              </a:rPr>
+              <a:t>讲解提示：趋势图回答"走向"，与预警/转化页配合；替换数据时保持 1-6 月顺序。</a:t>
             </a:r>
           </a:p>
         </p:txBody>

</xml_diff>